<commit_message>
thêm cập nhật dữ liệu
</commit_message>
<xml_diff>
--- a/Docs/thiết kế giao diện app/Presentation1.pptx
+++ b/Docs/thiết kế giao diện app/Presentation1.pptx
@@ -5,7 +5,7 @@
     <p:sldMasterId id="2147483648" r:id="rId1"/>
   </p:sldMasterIdLst>
   <p:notesMasterIdLst>
-    <p:notesMasterId r:id="rId13"/>
+    <p:notesMasterId r:id="rId14"/>
   </p:notesMasterIdLst>
   <p:sldIdLst>
     <p:sldId id="256" r:id="rId2"/>
@@ -19,6 +19,7 @@
     <p:sldId id="264" r:id="rId10"/>
     <p:sldId id="265" r:id="rId11"/>
     <p:sldId id="266" r:id="rId12"/>
+    <p:sldId id="268" r:id="rId13"/>
   </p:sldIdLst>
   <p:sldSz cx="12192000" cy="6858000"/>
   <p:notesSz cx="6858000" cy="9144000"/>
@@ -1008,7 +1009,7 @@
               <a:t> </a:t>
             </a:r>
             <a:r>
-              <a:rPr lang="en-US"/>
+              <a:rPr lang="en-US" dirty="0" err="1"/>
               <a:t>x,y</a:t>
             </a:r>
             <a:endParaRPr lang="en-US" dirty="0"/>
@@ -1042,6 +1043,142 @@
     <p:extLst>
       <p:ext uri="{BB962C8B-B14F-4D97-AF65-F5344CB8AC3E}">
         <p14:creationId xmlns:p14="http://schemas.microsoft.com/office/powerpoint/2010/main" val="3082384992"/>
+      </p:ext>
+    </p:extLst>
+  </p:cSld>
+  <p:clrMapOvr>
+    <a:masterClrMapping/>
+  </p:clrMapOvr>
+</p:notes>
+</file>
+
+<file path=ppt/notesSlides/notesSlide12.xml><?xml version="1.0" encoding="utf-8"?>
+<p:notes xmlns:a="http://schemas.openxmlformats.org/drawingml/2006/main" xmlns:r="http://schemas.openxmlformats.org/officeDocument/2006/relationships" xmlns:p="http://schemas.openxmlformats.org/presentationml/2006/main">
+  <p:cSld>
+    <p:spTree>
+      <p:nvGrpSpPr>
+        <p:cNvPr id="1" name=""/>
+        <p:cNvGrpSpPr/>
+        <p:nvPr/>
+      </p:nvGrpSpPr>
+      <p:grpSpPr>
+        <a:xfrm>
+          <a:off x="0" y="0"/>
+          <a:ext cx="0" cy="0"/>
+          <a:chOff x="0" y="0"/>
+          <a:chExt cx="0" cy="0"/>
+        </a:xfrm>
+      </p:grpSpPr>
+      <p:sp>
+        <p:nvSpPr>
+          <p:cNvPr id="2" name="Slide Image Placeholder 1"/>
+          <p:cNvSpPr>
+            <a:spLocks noGrp="1" noRot="1" noChangeAspect="1"/>
+          </p:cNvSpPr>
+          <p:nvPr>
+            <p:ph type="sldImg"/>
+          </p:nvPr>
+        </p:nvSpPr>
+        <p:spPr/>
+      </p:sp>
+      <p:sp>
+        <p:nvSpPr>
+          <p:cNvPr id="3" name="Notes Placeholder 2"/>
+          <p:cNvSpPr>
+            <a:spLocks noGrp="1"/>
+          </p:cNvSpPr>
+          <p:nvPr>
+            <p:ph type="body" idx="1"/>
+          </p:nvPr>
+        </p:nvSpPr>
+        <p:spPr/>
+        <p:txBody>
+          <a:bodyPr/>
+          <a:lstStyle/>
+          <a:p>
+            <a:r>
+              <a:rPr lang="en-US" dirty="0"/>
+              <a:t>MÀN 11 </a:t>
+            </a:r>
+            <a:r>
+              <a:rPr lang="en-US" dirty="0" err="1"/>
+              <a:t>là</a:t>
+            </a:r>
+            <a:r>
+              <a:rPr lang="en-US" dirty="0"/>
+              <a:t> </a:t>
+            </a:r>
+            <a:r>
+              <a:rPr lang="en-US" dirty="0" err="1"/>
+              <a:t>tổng</a:t>
+            </a:r>
+            <a:r>
+              <a:rPr lang="en-US" dirty="0"/>
+              <a:t> </a:t>
+            </a:r>
+            <a:r>
+              <a:rPr lang="en-US" dirty="0" err="1"/>
+              <a:t>thể</a:t>
+            </a:r>
+            <a:r>
+              <a:rPr lang="en-US" dirty="0"/>
+              <a:t> </a:t>
+            </a:r>
+            <a:r>
+              <a:rPr lang="en-US" dirty="0" err="1"/>
+              <a:t>nội</a:t>
+            </a:r>
+            <a:r>
+              <a:rPr lang="en-US" dirty="0"/>
+              <a:t> dung </a:t>
+            </a:r>
+            <a:r>
+              <a:rPr lang="en-US" dirty="0" err="1"/>
+              <a:t>của</a:t>
+            </a:r>
+            <a:r>
+              <a:rPr lang="en-US" dirty="0"/>
+              <a:t> 3 </a:t>
+            </a:r>
+            <a:r>
+              <a:rPr lang="en-US" dirty="0" err="1"/>
+              <a:t>màn</a:t>
+            </a:r>
+            <a:r>
+              <a:rPr lang="en-US"/>
+              <a:t> 1-8-10.</a:t>
+            </a:r>
+            <a:endParaRPr lang="en-GB" dirty="0"/>
+          </a:p>
+        </p:txBody>
+      </p:sp>
+      <p:sp>
+        <p:nvSpPr>
+          <p:cNvPr id="4" name="Slide Number Placeholder 3"/>
+          <p:cNvSpPr>
+            <a:spLocks noGrp="1"/>
+          </p:cNvSpPr>
+          <p:nvPr>
+            <p:ph type="sldNum" sz="quarter" idx="5"/>
+          </p:nvPr>
+        </p:nvSpPr>
+        <p:spPr/>
+        <p:txBody>
+          <a:bodyPr/>
+          <a:lstStyle/>
+          <a:p>
+            <a:fld id="{2FB88F73-A46D-4A1F-B2EB-583C7DFE7E94}" type="slidenum">
+              <a:rPr lang="en-GB" smtClean="0"/>
+              <a:t>12</a:t>
+            </a:fld>
+            <a:endParaRPr lang="en-GB"/>
+          </a:p>
+        </p:txBody>
+      </p:sp>
+    </p:spTree>
+    <p:extLst>
+      <p:ext uri="{BB962C8B-B14F-4D97-AF65-F5344CB8AC3E}">
+        <p14:creationId xmlns:p14="http://schemas.microsoft.com/office/powerpoint/2010/main" val="2442703279"/>
       </p:ext>
     </p:extLst>
   </p:cSld>
@@ -1204,6 +1341,124 @@
               <a:rPr lang="en-US" dirty="0"/>
               <a:t>MÀN 2, THỂ HIỆN ĐẶC TÍNH RIÊNG LẺ CỦA UAV1, INFORMATION, CHANGE INFORMATION SẼ ĐƯỢC CHÚ THÍCH RÕ HƠN Ở SLIDE KHÁC.</a:t>
             </a:r>
+          </a:p>
+          <a:p>
+            <a:pPr marL="0" marR="0" lvl="0" indent="0" algn="l" defTabSz="914400" rtl="0" eaLnBrk="1" fontAlgn="auto" latinLnBrk="0" hangingPunct="1">
+              <a:lnSpc>
+                <a:spcPct val="100000"/>
+              </a:lnSpc>
+              <a:spcBef>
+                <a:spcPts val="0"/>
+              </a:spcBef>
+              <a:spcAft>
+                <a:spcPts val="0"/>
+              </a:spcAft>
+              <a:buClrTx/>
+              <a:buSzTx/>
+              <a:buFontTx/>
+              <a:buNone/>
+              <a:tabLst/>
+              <a:defRPr/>
+            </a:pPr>
+            <a:r>
+              <a:rPr lang="en-US" dirty="0"/>
+              <a:t>Information : </a:t>
+            </a:r>
+            <a:r>
+              <a:rPr lang="en-US" dirty="0" err="1"/>
+              <a:t>vùng</a:t>
+            </a:r>
+            <a:r>
+              <a:rPr lang="en-US" dirty="0"/>
+              <a:t> </a:t>
+            </a:r>
+            <a:r>
+              <a:rPr lang="en-US" dirty="0" err="1"/>
+              <a:t>chỉ</a:t>
+            </a:r>
+            <a:r>
+              <a:rPr lang="en-US" dirty="0"/>
+              <a:t> </a:t>
+            </a:r>
+            <a:r>
+              <a:rPr lang="en-US" dirty="0" err="1"/>
+              <a:t>hiển</a:t>
+            </a:r>
+            <a:r>
+              <a:rPr lang="en-US" dirty="0"/>
+              <a:t> </a:t>
+            </a:r>
+            <a:r>
+              <a:rPr lang="en-US" dirty="0" err="1"/>
+              <a:t>thị</a:t>
+            </a:r>
+            <a:r>
+              <a:rPr lang="en-US" dirty="0"/>
+              <a:t> </a:t>
+            </a:r>
+            <a:r>
+              <a:rPr lang="en-US" dirty="0" err="1"/>
+              <a:t>thông</a:t>
+            </a:r>
+            <a:r>
+              <a:rPr lang="en-US" dirty="0"/>
+              <a:t> tin</a:t>
+            </a:r>
+          </a:p>
+          <a:p>
+            <a:pPr marL="0" marR="0" lvl="0" indent="0" algn="l" defTabSz="914400" rtl="0" eaLnBrk="1" fontAlgn="auto" latinLnBrk="0" hangingPunct="1">
+              <a:lnSpc>
+                <a:spcPct val="100000"/>
+              </a:lnSpc>
+              <a:spcBef>
+                <a:spcPts val="0"/>
+              </a:spcBef>
+              <a:spcAft>
+                <a:spcPts val="0"/>
+              </a:spcAft>
+              <a:buClrTx/>
+              <a:buSzTx/>
+              <a:buFontTx/>
+              <a:buNone/>
+              <a:tabLst/>
+              <a:defRPr/>
+            </a:pPr>
+            <a:r>
+              <a:rPr lang="en-US" dirty="0"/>
+              <a:t>Change </a:t>
+            </a:r>
+            <a:r>
+              <a:rPr lang="en-US" dirty="0" err="1"/>
+              <a:t>imfomation</a:t>
+            </a:r>
+            <a:r>
+              <a:rPr lang="en-US" dirty="0"/>
+              <a:t> : </a:t>
+            </a:r>
+            <a:r>
+              <a:rPr lang="en-US" dirty="0" err="1"/>
+              <a:t>vùng</a:t>
+            </a:r>
+            <a:r>
+              <a:rPr lang="en-US" dirty="0"/>
+              <a:t> </a:t>
+            </a:r>
+            <a:r>
+              <a:rPr lang="en-US" dirty="0" err="1"/>
+              <a:t>nhập</a:t>
+            </a:r>
+            <a:r>
+              <a:rPr lang="en-US" dirty="0"/>
+              <a:t> </a:t>
+            </a:r>
+            <a:r>
+              <a:rPr lang="en-US" dirty="0" err="1"/>
+              <a:t>thông</a:t>
+            </a:r>
+            <a:r>
+              <a:rPr lang="en-US" dirty="0"/>
+              <a:t> tin</a:t>
+            </a:r>
             <a:endParaRPr lang="en-GB" dirty="0"/>
           </a:p>
         </p:txBody>
@@ -1831,6 +2086,68 @@
             <a:r>
               <a:rPr lang="en-US" dirty="0"/>
               <a:t>MÀN 8 THỂ HIỆN CÁC VẤN ĐỀ LIÊN QUAN ĐẾN MAP VÀ LIÊN THÔNG DỮ LIỆU VỚI PHẦN ĐIỀU KHIỂN.</a:t>
+            </a:r>
+          </a:p>
+          <a:p>
+            <a:r>
+              <a:rPr lang="en-US" dirty="0"/>
+              <a:t>- </a:t>
+            </a:r>
+            <a:r>
+              <a:rPr lang="en-US" dirty="0" err="1"/>
+              <a:t>nhấn</a:t>
+            </a:r>
+            <a:r>
+              <a:rPr lang="en-US" dirty="0"/>
+              <a:t> </a:t>
+            </a:r>
+            <a:r>
+              <a:rPr lang="en-US" dirty="0" err="1"/>
+              <a:t>vào</a:t>
+            </a:r>
+            <a:r>
+              <a:rPr lang="en-US" dirty="0"/>
+              <a:t> </a:t>
+            </a:r>
+            <a:r>
+              <a:rPr lang="en-US" dirty="0" err="1"/>
+              <a:t>rescuemap</a:t>
+            </a:r>
+            <a:r>
+              <a:rPr lang="en-US" dirty="0"/>
+              <a:t> </a:t>
+            </a:r>
+            <a:r>
+              <a:rPr lang="en-US" dirty="0" err="1"/>
+              <a:t>thì</a:t>
+            </a:r>
+            <a:r>
+              <a:rPr lang="en-US" dirty="0"/>
+              <a:t> </a:t>
+            </a:r>
+            <a:r>
+              <a:rPr lang="en-US" dirty="0" err="1"/>
+              <a:t>hiển</a:t>
+            </a:r>
+            <a:r>
+              <a:rPr lang="en-US" dirty="0"/>
+              <a:t> </a:t>
+            </a:r>
+            <a:r>
+              <a:rPr lang="en-US" dirty="0" err="1"/>
+              <a:t>thị</a:t>
+            </a:r>
+            <a:r>
+              <a:rPr lang="en-US" dirty="0"/>
+              <a:t> </a:t>
+            </a:r>
+            <a:r>
+              <a:rPr lang="en-US" dirty="0" err="1"/>
+              <a:t>cột</a:t>
+            </a:r>
+            <a:r>
+              <a:rPr lang="en-US" dirty="0"/>
+              <a:t> option.</a:t>
             </a:r>
           </a:p>
           <a:p>
@@ -8288,7 +8605,7 @@
           <p:nvPr>
             <p:extLst>
               <p:ext uri="{D42A27DB-BD31-4B8C-83A1-F6EECF244321}">
-                <p14:modId xmlns:p14="http://schemas.microsoft.com/office/powerpoint/2010/main" val="2928144198"/>
+                <p14:modId xmlns:p14="http://schemas.microsoft.com/office/powerpoint/2010/main" val="1995083904"/>
               </p:ext>
             </p:extLst>
           </p:nvPr>
@@ -8379,7 +8696,7 @@
                       <a:pPr algn="ctr"/>
                       <a:r>
                         <a:rPr lang="en-US" dirty="0"/>
-                        <a:t>Source</a:t>
+                        <a:t>Source Video</a:t>
                       </a:r>
                       <a:endParaRPr lang="en-GB" dirty="0"/>
                     </a:p>
@@ -8394,7 +8711,7 @@
                       <a:pPr algn="ctr"/>
                       <a:r>
                         <a:rPr lang="en-US" dirty="0"/>
-                        <a:t>Enable Swarms</a:t>
+                        <a:t>Number Swarms</a:t>
                       </a:r>
                       <a:endParaRPr lang="en-GB" dirty="0"/>
                     </a:p>
@@ -8480,7 +8797,7 @@
                   </a:txBody>
                   <a:tcPr/>
                 </a:tc>
-                <a:tc>
+                <a:tc rowSpan="6">
                   <a:txBody>
                     <a:bodyPr/>
                     <a:lstStyle/>
@@ -8492,7 +8809,7 @@
                       </a:r>
                       <a:r>
                         <a:rPr lang="en-US" dirty="0" err="1"/>
-                        <a:t>lựa</a:t>
+                        <a:t>số</a:t>
                       </a:r>
                       <a:r>
                         <a:rPr lang="en-US" dirty="0"/>
@@ -8500,19 +8817,18 @@
                       </a:r>
                       <a:r>
                         <a:rPr lang="en-US" dirty="0" err="1"/>
-                        <a:t>chọn</a:t>
-                      </a:r>
-                      <a:r>
-                        <a:rPr lang="en-US" dirty="0"/>
-                        <a:t> </a:t>
-                      </a:r>
-                      <a:r>
-                        <a:rPr lang="en-US" dirty="0" err="1"/>
-                        <a:t>tích</a:t>
+                        <a:t>lượng</a:t>
                       </a:r>
                       <a:r>
                         <a:rPr lang="en-US" dirty="0"/>
                         <a:t>)</a:t>
+                      </a:r>
+                    </a:p>
+                    <a:p>
+                      <a:pPr algn="ctr"/>
+                      <a:r>
+                        <a:rPr lang="en-US" dirty="0"/>
+                        <a:t>2.</a:t>
                       </a:r>
                       <a:endParaRPr lang="en-GB" dirty="0"/>
                     </a:p>
@@ -8610,7 +8926,7 @@
                   </a:txBody>
                   <a:tcPr/>
                 </a:tc>
-                <a:tc>
+                <a:tc vMerge="1">
                   <a:txBody>
                     <a:bodyPr/>
                     <a:lstStyle/>
@@ -8684,7 +9000,7 @@
                   </a:txBody>
                   <a:tcPr/>
                 </a:tc>
-                <a:tc>
+                <a:tc vMerge="1">
                   <a:txBody>
                     <a:bodyPr/>
                     <a:lstStyle/>
@@ -8758,7 +9074,7 @@
                   </a:txBody>
                   <a:tcPr/>
                 </a:tc>
-                <a:tc>
+                <a:tc vMerge="1">
                   <a:txBody>
                     <a:bodyPr/>
                     <a:lstStyle/>
@@ -8832,7 +9148,7 @@
                   </a:txBody>
                   <a:tcPr/>
                 </a:tc>
-                <a:tc>
+                <a:tc vMerge="1">
                   <a:txBody>
                     <a:bodyPr/>
                     <a:lstStyle/>
@@ -8906,7 +9222,7 @@
                   </a:txBody>
                   <a:tcPr/>
                 </a:tc>
-                <a:tc>
+                <a:tc vMerge="1">
                   <a:txBody>
                     <a:bodyPr/>
                     <a:lstStyle/>
@@ -9931,6 +10247,549 @@
     <p:extLst>
       <p:ext uri="{BB962C8B-B14F-4D97-AF65-F5344CB8AC3E}">
         <p14:creationId xmlns:p14="http://schemas.microsoft.com/office/powerpoint/2010/main" val="3106330593"/>
+      </p:ext>
+    </p:extLst>
+  </p:cSld>
+  <p:clrMapOvr>
+    <a:masterClrMapping/>
+  </p:clrMapOvr>
+</p:sld>
+</file>
+
+<file path=ppt/slides/slide12.xml><?xml version="1.0" encoding="utf-8"?>
+<p:sld xmlns:a="http://schemas.openxmlformats.org/drawingml/2006/main" xmlns:r="http://schemas.openxmlformats.org/officeDocument/2006/relationships" xmlns:p="http://schemas.openxmlformats.org/presentationml/2006/main">
+  <p:cSld>
+    <p:spTree>
+      <p:nvGrpSpPr>
+        <p:cNvPr id="1" name=""/>
+        <p:cNvGrpSpPr/>
+        <p:nvPr/>
+      </p:nvGrpSpPr>
+      <p:grpSpPr>
+        <a:xfrm>
+          <a:off x="0" y="0"/>
+          <a:ext cx="0" cy="0"/>
+          <a:chOff x="0" y="0"/>
+          <a:chExt cx="0" cy="0"/>
+        </a:xfrm>
+      </p:grpSpPr>
+      <p:sp>
+        <p:nvSpPr>
+          <p:cNvPr id="4" name="Rectangle 3">
+            <a:extLst>
+              <a:ext uri="{FF2B5EF4-FFF2-40B4-BE49-F238E27FC236}">
+                <a16:creationId xmlns:a16="http://schemas.microsoft.com/office/drawing/2014/main" id="{656E89D0-7786-C53D-9926-82679D09DEE8}"/>
+              </a:ext>
+            </a:extLst>
+          </p:cNvPr>
+          <p:cNvSpPr/>
+          <p:nvPr/>
+        </p:nvSpPr>
+        <p:spPr>
+          <a:xfrm>
+            <a:off x="-16903" y="0"/>
+            <a:ext cx="12192000" cy="943947"/>
+          </a:xfrm>
+          <a:prstGeom prst="rect">
+            <a:avLst/>
+          </a:prstGeom>
+          <a:solidFill>
+            <a:srgbClr val="72E424"/>
+          </a:solidFill>
+        </p:spPr>
+        <p:style>
+          <a:lnRef idx="2">
+            <a:schemeClr val="accent1">
+              <a:shade val="15000"/>
+            </a:schemeClr>
+          </a:lnRef>
+          <a:fillRef idx="1">
+            <a:schemeClr val="accent1"/>
+          </a:fillRef>
+          <a:effectRef idx="0">
+            <a:schemeClr val="accent1"/>
+          </a:effectRef>
+          <a:fontRef idx="minor">
+            <a:schemeClr val="lt1"/>
+          </a:fontRef>
+        </p:style>
+        <p:txBody>
+          <a:bodyPr rtlCol="0" anchor="ctr"/>
+          <a:lstStyle/>
+          <a:p>
+            <a:endParaRPr lang="en-GB"/>
+          </a:p>
+        </p:txBody>
+      </p:sp>
+      <p:sp>
+        <p:nvSpPr>
+          <p:cNvPr id="8" name="Rectangle 7">
+            <a:extLst>
+              <a:ext uri="{FF2B5EF4-FFF2-40B4-BE49-F238E27FC236}">
+                <a16:creationId xmlns:a16="http://schemas.microsoft.com/office/drawing/2014/main" id="{E77F7A22-470E-3DF4-3B02-9B023A518593}"/>
+              </a:ext>
+            </a:extLst>
+          </p:cNvPr>
+          <p:cNvSpPr/>
+          <p:nvPr/>
+        </p:nvSpPr>
+        <p:spPr>
+          <a:xfrm>
+            <a:off x="2334899" y="-5080"/>
+            <a:ext cx="8341771" cy="954107"/>
+          </a:xfrm>
+          <a:prstGeom prst="rect">
+            <a:avLst/>
+          </a:prstGeom>
+          <a:noFill/>
+        </p:spPr>
+        <p:txBody>
+          <a:bodyPr wrap="none" lIns="91440" tIns="45720" rIns="91440" bIns="45720">
+            <a:spAutoFit/>
+          </a:bodyPr>
+          <a:lstStyle/>
+          <a:p>
+            <a:pPr algn="ctr"/>
+            <a:r>
+              <a:rPr lang="en-US" sz="2800" b="1" dirty="0">
+                <a:ln w="9525">
+                  <a:solidFill>
+                    <a:schemeClr val="bg1"/>
+                  </a:solidFill>
+                  <a:prstDash val="solid"/>
+                </a:ln>
+                <a:solidFill>
+                  <a:srgbClr val="FF0000"/>
+                </a:solidFill>
+                <a:effectLst>
+                  <a:outerShdw blurRad="12700" dist="38100" dir="2700000" algn="tl" rotWithShape="0">
+                    <a:schemeClr val="bg1">
+                      <a:lumMod val="50000"/>
+                    </a:schemeClr>
+                  </a:outerShdw>
+                </a:effectLst>
+              </a:rPr>
+              <a:t>INTELLIGENT </a:t>
+            </a:r>
+            <a:r>
+              <a:rPr lang="en-GB" sz="2800" b="1" dirty="0">
+                <a:ln w="9525">
+                  <a:solidFill>
+                    <a:schemeClr val="bg1"/>
+                  </a:solidFill>
+                  <a:prstDash val="solid"/>
+                </a:ln>
+                <a:solidFill>
+                  <a:srgbClr val="FF0000"/>
+                </a:solidFill>
+                <a:effectLst>
+                  <a:outerShdw blurRad="12700" dist="38100" dir="2700000" algn="tl" rotWithShape="0">
+                    <a:schemeClr val="bg1">
+                      <a:lumMod val="50000"/>
+                    </a:schemeClr>
+                  </a:outerShdw>
+                </a:effectLst>
+              </a:rPr>
+              <a:t>MONITORING AND CONTROL SOFTWARE </a:t>
+            </a:r>
+          </a:p>
+          <a:p>
+            <a:pPr algn="ctr"/>
+            <a:r>
+              <a:rPr lang="en-GB" sz="2800" b="1" dirty="0">
+                <a:ln w="9525">
+                  <a:solidFill>
+                    <a:schemeClr val="bg1"/>
+                  </a:solidFill>
+                  <a:prstDash val="solid"/>
+                </a:ln>
+                <a:solidFill>
+                  <a:srgbClr val="FF0000"/>
+                </a:solidFill>
+                <a:effectLst>
+                  <a:outerShdw blurRad="12700" dist="38100" dir="2700000" algn="tl" rotWithShape="0">
+                    <a:schemeClr val="bg1">
+                      <a:lumMod val="50000"/>
+                    </a:schemeClr>
+                  </a:outerShdw>
+                </a:effectLst>
+              </a:rPr>
+              <a:t>FOR DRONE SWARMS</a:t>
+            </a:r>
+            <a:r>
+              <a:rPr lang="en-US" sz="2800" b="1" dirty="0">
+                <a:ln w="9525">
+                  <a:solidFill>
+                    <a:schemeClr val="bg1"/>
+                  </a:solidFill>
+                  <a:prstDash val="solid"/>
+                </a:ln>
+                <a:solidFill>
+                  <a:srgbClr val="FF0000"/>
+                </a:solidFill>
+                <a:effectLst>
+                  <a:outerShdw blurRad="12700" dist="38100" dir="2700000" algn="tl" rotWithShape="0">
+                    <a:schemeClr val="bg1">
+                      <a:lumMod val="50000"/>
+                    </a:schemeClr>
+                  </a:outerShdw>
+                </a:effectLst>
+              </a:rPr>
+              <a:t>  </a:t>
+            </a:r>
+            <a:endParaRPr lang="en-US" sz="2800" b="1" cap="none" spc="0" dirty="0">
+              <a:ln w="9525">
+                <a:solidFill>
+                  <a:schemeClr val="bg1"/>
+                </a:solidFill>
+                <a:prstDash val="solid"/>
+              </a:ln>
+              <a:solidFill>
+                <a:srgbClr val="FF0000"/>
+              </a:solidFill>
+              <a:effectLst>
+                <a:outerShdw blurRad="12700" dist="38100" dir="2700000" algn="tl" rotWithShape="0">
+                  <a:schemeClr val="bg1">
+                    <a:lumMod val="50000"/>
+                  </a:schemeClr>
+                </a:outerShdw>
+              </a:effectLst>
+            </a:endParaRPr>
+          </a:p>
+        </p:txBody>
+      </p:sp>
+      <p:pic>
+        <p:nvPicPr>
+          <p:cNvPr id="18" name="Picture 17" descr="A blue and white circle with text&#10;&#10;Description automatically generated">
+            <a:extLst>
+              <a:ext uri="{FF2B5EF4-FFF2-40B4-BE49-F238E27FC236}">
+                <a16:creationId xmlns:a16="http://schemas.microsoft.com/office/drawing/2014/main" id="{FEFF53A4-85DA-63FC-3D4E-F907CFE393EF}"/>
+              </a:ext>
+            </a:extLst>
+          </p:cNvPr>
+          <p:cNvPicPr>
+            <a:picLocks noChangeAspect="1"/>
+          </p:cNvPicPr>
+          <p:nvPr/>
+        </p:nvPicPr>
+        <p:blipFill>
+          <a:blip r:embed="rId3">
+            <a:extLst>
+              <a:ext uri="{28A0092B-C50C-407E-A947-70E740481C1C}">
+                <a14:useLocalDpi xmlns:a14="http://schemas.microsoft.com/office/drawing/2010/main" val="0"/>
+              </a:ext>
+            </a:extLst>
+          </a:blip>
+          <a:stretch>
+            <a:fillRect/>
+          </a:stretch>
+        </p:blipFill>
+        <p:spPr>
+          <a:xfrm>
+            <a:off x="1202384" y="19853"/>
+            <a:ext cx="904240" cy="904240"/>
+          </a:xfrm>
+          <a:prstGeom prst="rect">
+            <a:avLst/>
+          </a:prstGeom>
+        </p:spPr>
+      </p:pic>
+      <p:pic>
+        <p:nvPicPr>
+          <p:cNvPr id="20" name="Picture 19" descr="A blue and white logo&#10;&#10;Description automatically generated">
+            <a:extLst>
+              <a:ext uri="{FF2B5EF4-FFF2-40B4-BE49-F238E27FC236}">
+                <a16:creationId xmlns:a16="http://schemas.microsoft.com/office/drawing/2014/main" id="{953AF7C6-BC9C-9020-F02B-0BBEBFD9FEF7}"/>
+              </a:ext>
+            </a:extLst>
+          </p:cNvPr>
+          <p:cNvPicPr>
+            <a:picLocks noChangeAspect="1"/>
+          </p:cNvPicPr>
+          <p:nvPr/>
+        </p:nvPicPr>
+        <p:blipFill>
+          <a:blip r:embed="rId4">
+            <a:extLst>
+              <a:ext uri="{28A0092B-C50C-407E-A947-70E740481C1C}">
+                <a14:useLocalDpi xmlns:a14="http://schemas.microsoft.com/office/drawing/2010/main" val="0"/>
+              </a:ext>
+            </a:extLst>
+          </a:blip>
+          <a:stretch>
+            <a:fillRect/>
+          </a:stretch>
+        </p:blipFill>
+        <p:spPr>
+          <a:xfrm>
+            <a:off x="151556" y="19853"/>
+            <a:ext cx="904240" cy="904240"/>
+          </a:xfrm>
+          <a:prstGeom prst="rect">
+            <a:avLst/>
+          </a:prstGeom>
+        </p:spPr>
+      </p:pic>
+      <p:sp>
+        <p:nvSpPr>
+          <p:cNvPr id="21" name="Rectangle 20">
+            <a:extLst>
+              <a:ext uri="{FF2B5EF4-FFF2-40B4-BE49-F238E27FC236}">
+                <a16:creationId xmlns:a16="http://schemas.microsoft.com/office/drawing/2014/main" id="{1DF674A3-0FE2-F14C-6D06-823D3787086C}"/>
+              </a:ext>
+            </a:extLst>
+          </p:cNvPr>
+          <p:cNvSpPr/>
+          <p:nvPr/>
+        </p:nvSpPr>
+        <p:spPr>
+          <a:xfrm>
+            <a:off x="10671812" y="0"/>
+            <a:ext cx="1501666" cy="434311"/>
+          </a:xfrm>
+          <a:prstGeom prst="rect">
+            <a:avLst/>
+          </a:prstGeom>
+          <a:solidFill>
+            <a:srgbClr val="FFFF00"/>
+          </a:solidFill>
+        </p:spPr>
+        <p:style>
+          <a:lnRef idx="2">
+            <a:schemeClr val="accent1">
+              <a:shade val="15000"/>
+            </a:schemeClr>
+          </a:lnRef>
+          <a:fillRef idx="1">
+            <a:schemeClr val="accent1"/>
+          </a:fillRef>
+          <a:effectRef idx="0">
+            <a:schemeClr val="accent1"/>
+          </a:effectRef>
+          <a:fontRef idx="minor">
+            <a:schemeClr val="lt1"/>
+          </a:fontRef>
+        </p:style>
+        <p:txBody>
+          <a:bodyPr rtlCol="0" anchor="ctr"/>
+          <a:lstStyle/>
+          <a:p>
+            <a:pPr algn="ctr"/>
+            <a:r>
+              <a:rPr lang="en-US" b="1" dirty="0">
+                <a:solidFill>
+                  <a:srgbClr val="FF0000"/>
+                </a:solidFill>
+                <a:latin typeface="Arial" panose="020B0604020202020204" pitchFamily="34" charset="0"/>
+                <a:cs typeface="Arial" panose="020B0604020202020204" pitchFamily="34" charset="0"/>
+              </a:rPr>
+              <a:t>SCREEN11</a:t>
+            </a:r>
+            <a:endParaRPr lang="en-GB" b="1" dirty="0">
+              <a:solidFill>
+                <a:srgbClr val="FF0000"/>
+              </a:solidFill>
+              <a:latin typeface="Arial" panose="020B0604020202020204" pitchFamily="34" charset="0"/>
+              <a:cs typeface="Arial" panose="020B0604020202020204" pitchFamily="34" charset="0"/>
+            </a:endParaRPr>
+          </a:p>
+        </p:txBody>
+      </p:sp>
+      <p:sp>
+        <p:nvSpPr>
+          <p:cNvPr id="22" name="Rectangle 21">
+            <a:extLst>
+              <a:ext uri="{FF2B5EF4-FFF2-40B4-BE49-F238E27FC236}">
+                <a16:creationId xmlns:a16="http://schemas.microsoft.com/office/drawing/2014/main" id="{BA1C007A-94AC-C7CC-E09D-B897E079A067}"/>
+              </a:ext>
+            </a:extLst>
+          </p:cNvPr>
+          <p:cNvSpPr/>
+          <p:nvPr/>
+        </p:nvSpPr>
+        <p:spPr>
+          <a:xfrm>
+            <a:off x="10670193" y="434311"/>
+            <a:ext cx="1501666" cy="502950"/>
+          </a:xfrm>
+          <a:prstGeom prst="rect">
+            <a:avLst/>
+          </a:prstGeom>
+          <a:solidFill>
+            <a:srgbClr val="FFFF00"/>
+          </a:solidFill>
+        </p:spPr>
+        <p:style>
+          <a:lnRef idx="2">
+            <a:schemeClr val="accent1">
+              <a:shade val="15000"/>
+            </a:schemeClr>
+          </a:lnRef>
+          <a:fillRef idx="1">
+            <a:schemeClr val="accent1"/>
+          </a:fillRef>
+          <a:effectRef idx="0">
+            <a:schemeClr val="accent1"/>
+          </a:effectRef>
+          <a:fontRef idx="minor">
+            <a:schemeClr val="lt1"/>
+          </a:fontRef>
+        </p:style>
+        <p:txBody>
+          <a:bodyPr rtlCol="0" anchor="ctr"/>
+          <a:lstStyle/>
+          <a:p>
+            <a:pPr algn="ctr"/>
+            <a:r>
+              <a:rPr lang="en-US" b="1" dirty="0">
+                <a:solidFill>
+                  <a:srgbClr val="FF0000"/>
+                </a:solidFill>
+                <a:latin typeface="Arial" panose="020B0604020202020204" pitchFamily="34" charset="0"/>
+                <a:cs typeface="Arial" panose="020B0604020202020204" pitchFamily="34" charset="0"/>
+              </a:rPr>
+              <a:t>ALL</a:t>
+            </a:r>
+          </a:p>
+          <a:p>
+            <a:pPr algn="ctr"/>
+            <a:r>
+              <a:rPr lang="en-US" b="1" dirty="0">
+                <a:solidFill>
+                  <a:srgbClr val="FF0000"/>
+                </a:solidFill>
+                <a:latin typeface="Arial" panose="020B0604020202020204" pitchFamily="34" charset="0"/>
+                <a:cs typeface="Arial" panose="020B0604020202020204" pitchFamily="34" charset="0"/>
+              </a:rPr>
+              <a:t>GENERAL</a:t>
+            </a:r>
+          </a:p>
+        </p:txBody>
+      </p:sp>
+      <p:pic>
+        <p:nvPicPr>
+          <p:cNvPr id="7" name="Picture 6">
+            <a:extLst>
+              <a:ext uri="{FF2B5EF4-FFF2-40B4-BE49-F238E27FC236}">
+                <a16:creationId xmlns:a16="http://schemas.microsoft.com/office/drawing/2014/main" id="{CE4971FF-DCA5-5E59-091E-09D6550A970B}"/>
+              </a:ext>
+            </a:extLst>
+          </p:cNvPr>
+          <p:cNvPicPr>
+            <a:picLocks noChangeAspect="1"/>
+          </p:cNvPicPr>
+          <p:nvPr/>
+        </p:nvPicPr>
+        <p:blipFill>
+          <a:blip r:embed="rId5"/>
+          <a:stretch>
+            <a:fillRect/>
+          </a:stretch>
+        </p:blipFill>
+        <p:spPr>
+          <a:xfrm>
+            <a:off x="-1" y="6351103"/>
+            <a:ext cx="12171859" cy="487043"/>
+          </a:xfrm>
+          <a:prstGeom prst="rect">
+            <a:avLst/>
+          </a:prstGeom>
+        </p:spPr>
+      </p:pic>
+      <p:pic>
+        <p:nvPicPr>
+          <p:cNvPr id="9" name="Picture 8">
+            <a:extLst>
+              <a:ext uri="{FF2B5EF4-FFF2-40B4-BE49-F238E27FC236}">
+                <a16:creationId xmlns:a16="http://schemas.microsoft.com/office/drawing/2014/main" id="{880A3C91-B58D-744E-0A18-B81EECB128F7}"/>
+              </a:ext>
+            </a:extLst>
+          </p:cNvPr>
+          <p:cNvPicPr>
+            <a:picLocks noChangeAspect="1"/>
+          </p:cNvPicPr>
+          <p:nvPr/>
+        </p:nvPicPr>
+        <p:blipFill>
+          <a:blip r:embed="rId6"/>
+          <a:stretch>
+            <a:fillRect/>
+          </a:stretch>
+        </p:blipFill>
+        <p:spPr>
+          <a:xfrm>
+            <a:off x="0" y="913933"/>
+            <a:ext cx="5254562" cy="5432090"/>
+          </a:xfrm>
+          <a:prstGeom prst="rect">
+            <a:avLst/>
+          </a:prstGeom>
+        </p:spPr>
+      </p:pic>
+      <p:pic>
+        <p:nvPicPr>
+          <p:cNvPr id="10" name="Picture 9">
+            <a:extLst>
+              <a:ext uri="{FF2B5EF4-FFF2-40B4-BE49-F238E27FC236}">
+                <a16:creationId xmlns:a16="http://schemas.microsoft.com/office/drawing/2014/main" id="{A3F9898F-38FB-A3E0-D894-6B96CCF385C7}"/>
+              </a:ext>
+            </a:extLst>
+          </p:cNvPr>
+          <p:cNvPicPr>
+            <a:picLocks noChangeAspect="1"/>
+          </p:cNvPicPr>
+          <p:nvPr/>
+        </p:nvPicPr>
+        <p:blipFill>
+          <a:blip r:embed="rId7"/>
+          <a:stretch>
+            <a:fillRect/>
+          </a:stretch>
+        </p:blipFill>
+        <p:spPr>
+          <a:xfrm>
+            <a:off x="5208104" y="938977"/>
+            <a:ext cx="6983896" cy="3677749"/>
+          </a:xfrm>
+          <a:prstGeom prst="rect">
+            <a:avLst/>
+          </a:prstGeom>
+        </p:spPr>
+      </p:pic>
+      <p:pic>
+        <p:nvPicPr>
+          <p:cNvPr id="11" name="Picture 10">
+            <a:extLst>
+              <a:ext uri="{FF2B5EF4-FFF2-40B4-BE49-F238E27FC236}">
+                <a16:creationId xmlns:a16="http://schemas.microsoft.com/office/drawing/2014/main" id="{941C0A4E-91D1-4880-D500-B2BB3CAAB7C6}"/>
+              </a:ext>
+            </a:extLst>
+          </p:cNvPr>
+          <p:cNvPicPr>
+            <a:picLocks noChangeAspect="1"/>
+          </p:cNvPicPr>
+          <p:nvPr/>
+        </p:nvPicPr>
+        <p:blipFill>
+          <a:blip r:embed="rId8"/>
+          <a:stretch>
+            <a:fillRect/>
+          </a:stretch>
+        </p:blipFill>
+        <p:spPr>
+          <a:xfrm>
+            <a:off x="5257800" y="4628382"/>
+            <a:ext cx="6923997" cy="1717641"/>
+          </a:xfrm>
+          <a:prstGeom prst="rect">
+            <a:avLst/>
+          </a:prstGeom>
+        </p:spPr>
+      </p:pic>
+    </p:spTree>
+    <p:extLst>
+      <p:ext uri="{BB962C8B-B14F-4D97-AF65-F5344CB8AC3E}">
+        <p14:creationId xmlns:p14="http://schemas.microsoft.com/office/powerpoint/2010/main" val="602887333"/>
       </p:ext>
     </p:extLst>
   </p:cSld>
@@ -15541,7 +16400,7 @@
                 <a:latin typeface="Arial" panose="020B0604020202020204" pitchFamily="34" charset="0"/>
                 <a:cs typeface="Arial" panose="020B0604020202020204" pitchFamily="34" charset="0"/>
               </a:rPr>
-              <a:t>1</a:t>
+              <a:t>3</a:t>
             </a:r>
           </a:p>
           <a:p>
@@ -15619,7 +16478,7 @@
                 <a:latin typeface="Arial" panose="020B0604020202020204" pitchFamily="34" charset="0"/>
                 <a:cs typeface="Arial" panose="020B0604020202020204" pitchFamily="34" charset="0"/>
               </a:rPr>
-              <a:t>1</a:t>
+              <a:t>3</a:t>
             </a:r>
           </a:p>
           <a:p>

</xml_diff>